<commit_message>
Replace legacy logo with official MR logo across all presentations (PPTX, PDF, HTML) and dossiers
</commit_message>
<xml_diff>
--- a/MANDOROS_Global_Academic_Presentation.pptx
+++ b/MANDOROS_Global_Academic_Presentation.pptx
@@ -3144,7 +3144,7 @@
       </p:sp>
       <p:pic>
         <p:nvPicPr>
-          <p:cNvPr id="3" name="Picture 2" descr="mandoros_logo_transparent.png"/>
+          <p:cNvPr id="3" name="Picture 2" descr="mr_logo_master.png"/>
           <p:cNvPicPr>
             <a:picLocks noChangeAspect="1"/>
           </p:cNvPicPr>
@@ -4684,7 +4684,7 @@
       </p:sp>
       <p:pic>
         <p:nvPicPr>
-          <p:cNvPr id="3" name="Picture 2" descr="mandoros_logo_transparent.png"/>
+          <p:cNvPr id="3" name="Picture 2" descr="mr_logo_master.png"/>
           <p:cNvPicPr>
             <a:picLocks noChangeAspect="1"/>
           </p:cNvPicPr>

</xml_diff>